<commit_message>
Site-wide period picker: home dashboard for every month, carried to reports and cards
- Home dashboard Period picker, Nov 2024 to Oct 2026 to date, built per month from the ledger (dashboard_months.py); September validated against the model
- Picked month carries through the visit (sessionStorage / ?period=): report pages, cards and featured charts; reports without that month fall back and say so
- Balance sheet, cash flow and export pack for September 2026 only; other months say so
- History headcount and October hours fixed so utilisation stays believable
- Report pages load reports-data.js once

Co-Authored-By: Claude Opus 5.5 <noreply@anthropic.com>
</commit_message>
<xml_diff>
--- a/media/exports/reports/2025-10/calls.pptx
+++ b/media/exports/reports/2025-10/calls.pptx
@@ -235,25 +235,25 @@
                 <c:formatCode>#,##0;[Red](#,##0)</c:formatCode>
                 <c:ptCount val="7"/>
                 <c:pt idx="0">
-                  <c:v>90</c:v>
+                  <c:v>101</c:v>
                 </c:pt>
                 <c:pt idx="1">
-                  <c:v>151</c:v>
+                  <c:v>134</c:v>
                 </c:pt>
                 <c:pt idx="2">
-                  <c:v>125</c:v>
+                  <c:v>126</c:v>
                 </c:pt>
                 <c:pt idx="3">
-                  <c:v>92</c:v>
+                  <c:v>89</c:v>
                 </c:pt>
                 <c:pt idx="4">
-                  <c:v>119</c:v>
+                  <c:v>108</c:v>
                 </c:pt>
                 <c:pt idx="5">
-                  <c:v>85</c:v>
+                  <c:v>88</c:v>
                 </c:pt>
                 <c:pt idx="6">
-                  <c:v>130</c:v>
+                  <c:v>124</c:v>
                 </c:pt>
               </c:numCache>
             </c:numRef>
@@ -317,7 +317,7 @@
       <c:valAx>
         <c:axId val="-2113994440"/>
         <c:scaling>
-          <c:max val="173.64999999999998"/>
+          <c:max val="154.1"/>
           <c:min val="0.0"/>
         </c:scaling>
         <c:delete/>
@@ -450,43 +450,43 @@
                 <c:formatCode>#,##0;[Red](#,##0)</c:formatCode>
                 <c:ptCount val="13"/>
                 <c:pt idx="0">
-                  <c:v>659</c:v>
+                  <c:v>685</c:v>
                 </c:pt>
                 <c:pt idx="1">
-                  <c:v>655</c:v>
+                  <c:v>633</c:v>
                 </c:pt>
                 <c:pt idx="2">
+                  <c:v>684</c:v>
+                </c:pt>
+                <c:pt idx="3">
+                  <c:v>690</c:v>
+                </c:pt>
+                <c:pt idx="4">
+                  <c:v>664</c:v>
+                </c:pt>
+                <c:pt idx="5">
                   <c:v>685</c:v>
                 </c:pt>
-                <c:pt idx="3">
-                  <c:v>714</c:v>
-                </c:pt>
-                <c:pt idx="4">
-                  <c:v>683</c:v>
-                </c:pt>
-                <c:pt idx="5">
-                  <c:v>725</c:v>
-                </c:pt>
                 <c:pt idx="6">
-                  <c:v>620</c:v>
+                  <c:v>629</c:v>
                 </c:pt>
                 <c:pt idx="7">
-                  <c:v>754</c:v>
+                  <c:v>724</c:v>
                 </c:pt>
                 <c:pt idx="8">
-                  <c:v>783</c:v>
+                  <c:v>820</c:v>
                 </c:pt>
                 <c:pt idx="9">
-                  <c:v>871</c:v>
+                  <c:v>909</c:v>
                 </c:pt>
                 <c:pt idx="10">
-                  <c:v>852</c:v>
+                  <c:v>826</c:v>
                 </c:pt>
                 <c:pt idx="11">
-                  <c:v>781</c:v>
+                  <c:v>756</c:v>
                 </c:pt>
                 <c:pt idx="12">
-                  <c:v>792</c:v>
+                  <c:v>770</c:v>
                 </c:pt>
               </c:numCache>
             </c:numRef>
@@ -1060,7 +1060,7 @@
           <a:lstStyle/>
           <a:p>
             <a:r>
-              <a:t>When do calls for help come in, and are we there to answer?. Calls for help, October: 792; Answered while staffed, October: 81.9%; Calls outside staffed hours, October: 54.0%; Median wait when answered, October: 80 sec. 792 calls for help came in during October. While the line was staffed, 81.9% were answered (target 90.0%); 54.0% of all calls came outside staffed hours and went to voicemail. The busiest time was 5 to 8pm (151 calls). 151 calls came between 5 and 8pm, when no-one is on the line. 66 callers hung up waiting while the line was staffed.</a:t>
+              <a:t>When do calls for help come in, and are we there to answer?. Calls for help, October: 770; Answered while staffed, October: 83.7%; Calls outside staffed hours, October: 52.9%; Median wait when answered, October: 88 sec. 770 calls for help came in during October. While the line was staffed, 83.7% were answered (target 90.0%); 52.9% of all calls came outside staffed hours and went to voicemail. The busiest time was 5 to 8pm (134 calls). 134 calls came between 5 and 8pm, when no-one is on the line. 59 callers hung up waiting while the line was staffed.</a:t>
             </a:r>
           </a:p>
         </p:txBody>
@@ -4545,7 +4545,7 @@
                 </a:solidFill>
                 <a:latin typeface="Roboto"/>
               </a:rPr>
-              <a:t>Data retrieved 2pm, Tue 6 Oct 2026 · Generated 8 Oct 2026, 6:42pm · Sample data · Made with Python (python-pptx)</a:t>
+              <a:t>Data retrieved 2pm, Tue 6 Oct 2026 · Generated 8 Oct 2026, 11:41pm · Sample data · Made with Python (python-pptx)</a:t>
             </a:r>
           </a:p>
         </p:txBody>
@@ -4891,7 +4891,7 @@
                 </a:solidFill>
                 <a:latin typeface="Roboto"/>
               </a:rPr>
-              <a:t>792</a:t>
+              <a:t>770</a:t>
             </a:r>
           </a:p>
         </p:txBody>
@@ -4930,7 +4930,7 @@
                 </a:solidFill>
                 <a:latin typeface="Roboto"/>
               </a:rPr>
-              <a:t>September 781</a:t>
+              <a:t>September 756</a:t>
             </a:r>
           </a:p>
         </p:txBody>
@@ -5057,7 +5057,7 @@
                 </a:solidFill>
                 <a:latin typeface="Roboto"/>
               </a:rPr>
-              <a:t>81.9%</a:t>
+              <a:t>83.7%</a:t>
             </a:r>
           </a:p>
         </p:txBody>
@@ -5223,7 +5223,7 @@
                 </a:solidFill>
                 <a:latin typeface="Roboto"/>
               </a:rPr>
-              <a:t>54.0%</a:t>
+              <a:t>52.9%</a:t>
             </a:r>
           </a:p>
         </p:txBody>
@@ -5262,7 +5262,7 @@
                 </a:solidFill>
                 <a:latin typeface="Roboto"/>
               </a:rPr>
-              <a:t>428 calls to voicemail</a:t>
+              <a:t>407 calls to voicemail</a:t>
             </a:r>
           </a:p>
         </p:txBody>
@@ -5389,7 +5389,7 @@
                 </a:solidFill>
                 <a:latin typeface="Roboto"/>
               </a:rPr>
-              <a:t>80 sec</a:t>
+              <a:t>88 sec</a:t>
             </a:r>
           </a:p>
         </p:txBody>
@@ -5428,7 +5428,7 @@
                 </a:solidFill>
                 <a:latin typeface="Roboto"/>
               </a:rPr>
-              <a:t>298 answered calls</a:t>
+              <a:t>304 answered calls</a:t>
             </a:r>
           </a:p>
         </p:txBody>
@@ -5573,7 +5573,7 @@
                 </a:solidFill>
                 <a:latin typeface="Roboto"/>
               </a:rPr>
-              <a:t>792 calls for help came in during October. While the line was staffed, 81.9% were answered (target 90.0%); 54.0% of all calls came outside staffed hours and went to voicemail. The busiest time was 5 to 8pm (151 calls).</a:t>
+              <a:t>770 calls for help came in during October. While the line was staffed, 83.7% were answered (target 90.0%); 52.9% of all calls came outside staffed hours and went to voicemail. The busiest time was 5 to 8pm (134 calls).</a:t>
             </a:r>
           </a:p>
         </p:txBody>
@@ -5700,7 +5700,7 @@
                 </a:solidFill>
                 <a:latin typeface="Roboto"/>
               </a:rPr>
-              <a:t>151 calls came between 5 and 8pm, when no-one is on the line. 66 callers hung up waiting while the line was staffed.</a:t>
+              <a:t>134 calls came between 5 and 8pm, when no-one is on the line. 59 callers hung up waiting while the line was staffed.</a:t>
             </a:r>
           </a:p>
         </p:txBody>
@@ -5778,7 +5778,7 @@
                 </a:solidFill>
                 <a:latin typeface="Roboto"/>
               </a:rPr>
-              <a:t>Data retrieved 2pm, Tue 6 Oct 2026 · Generated 8 Oct 2026, 6:42pm · Sample data · Made with Python (python-pptx)</a:t>
+              <a:t>Data retrieved 2pm, Tue 6 Oct 2026 · Generated 8 Oct 2026, 11:41pm · Sample data · Made with Python (python-pptx)</a:t>
             </a:r>
           </a:p>
         </p:txBody>
@@ -6093,7 +6093,7 @@
                 </a:solidFill>
                 <a:latin typeface="Roboto"/>
               </a:rPr>
-              <a:t>Data retrieved 2pm, Tue 6 Oct 2026 · Generated 8 Oct 2026, 6:42pm · Sample data · Made with Python (python-pptx)</a:t>
+              <a:t>Data retrieved 2pm, Tue 6 Oct 2026 · Generated 8 Oct 2026, 11:41pm · Sample data · Made with Python (python-pptx)</a:t>
             </a:r>
           </a:p>
         </p:txBody>

</xml_diff>